<commit_message>
Organisation du module : les 5 étapes réelles du chapitre 1
Co-Authored-By: Claude Opus 5.5 <noreply@anthropic.com>
Claude-Session: https://claude.ai/code/session_01F1WcwdyeyZPGZbyqYJ6PXE
</commit_message>
<xml_diff>
--- a/projets/Organisation_Module_L3_ELN.pptx
+++ b/projets/Organisation_Module_L3_ELN.pptx
@@ -1570,7 +1570,7 @@
                 <a:ea typeface="Calibri" pitchFamily="34" charset="-122"/>
                 <a:cs typeface="Calibri" pitchFamily="34" charset="-120"/>
               </a:rPr>
-              <a:t>Nous avons vu les cinq étapes de conception d'un projet électronique, illustrées par l'exemple de la lampe automatique.</a:t>
+              <a:t>Nous avons vu les cinq étapes de la conception d'un projet, dans un ordre à respecter : chaque étape prépare la suivante. Exemple : la lampe automatique.</a:t>
             </a:r>
             <a:endParaRPr lang="en-US" sz="1800" dirty="0"/>
           </a:p>
@@ -1707,7 +1707,7 @@
                 <a:ea typeface="Cambria" pitchFamily="34" charset="-122"/>
                 <a:cs typeface="Cambria" pitchFamily="34" charset="-120"/>
               </a:rPr>
-              <a:t>Cahier des charges</a:t>
+              <a:t>Analyser le besoin</a:t>
             </a:r>
             <a:endParaRPr lang="en-US" sz="1700" dirty="0"/>
           </a:p>
@@ -1746,7 +1746,7 @@
                 <a:ea typeface="Calibri" pitchFamily="34" charset="-122"/>
                 <a:cs typeface="Calibri" pitchFamily="34" charset="-120"/>
               </a:rPr>
-              <a:t>Définir le besoin et les contraintes</a:t>
+              <a:t>Quel problème ?</a:t>
             </a:r>
             <a:endParaRPr lang="en-US" sz="1400" dirty="0"/>
           </a:p>
@@ -1755,6 +1755,31 @@
       <p:sp>
         <p:nvSpPr>
           <p:cNvPr id="9" name="Shape 7"/>
+          <p:cNvSpPr/>
+          <p:nvPr/>
+        </p:nvSpPr>
+        <p:spPr>
+          <a:xfrm>
+            <a:off x="2706624" y="4160520"/>
+            <a:ext cx="128016" cy="182880"/>
+          </a:xfrm>
+          <a:prstGeom prst="rightArrow">
+            <a:avLst/>
+          </a:prstGeom>
+          <a:solidFill>
+            <a:srgbClr val="2C5596"/>
+          </a:solidFill>
+          <a:ln w="12700">
+            <a:solidFill>
+              <a:srgbClr val="2C5596"/>
+            </a:solidFill>
+            <a:prstDash val="solid"/>
+          </a:ln>
+        </p:spPr>
+      </p:sp>
+      <p:sp>
+        <p:nvSpPr>
+          <p:cNvPr id="10" name="Shape 8"/>
           <p:cNvSpPr/>
           <p:nvPr/>
         </p:nvSpPr>
@@ -1788,7 +1813,7 @@
       </p:sp>
       <p:sp>
         <p:nvSpPr>
-          <p:cNvPr id="10" name="Shape 8"/>
+          <p:cNvPr id="11" name="Shape 9"/>
           <p:cNvSpPr/>
           <p:nvPr/>
         </p:nvSpPr>
@@ -1813,7 +1838,7 @@
       </p:sp>
       <p:sp>
         <p:nvSpPr>
-          <p:cNvPr id="11" name="Text 9"/>
+          <p:cNvPr id="12" name="Text 10"/>
           <p:cNvSpPr txBox="1"/>
           <p:nvPr/>
         </p:nvSpPr>
@@ -1852,7 +1877,7 @@
       </p:sp>
       <p:sp>
         <p:nvSpPr>
-          <p:cNvPr id="12" name="Text 10"/>
+          <p:cNvPr id="13" name="Text 11"/>
           <p:cNvSpPr txBox="1"/>
           <p:nvPr/>
         </p:nvSpPr>
@@ -1883,7 +1908,7 @@
                 <a:ea typeface="Cambria" pitchFamily="34" charset="-122"/>
                 <a:cs typeface="Cambria" pitchFamily="34" charset="-120"/>
               </a:rPr>
-              <a:t>Étude des solutions</a:t>
+              <a:t>Écrire le cahier des charges</a:t>
             </a:r>
             <a:endParaRPr lang="en-US" sz="1700" dirty="0"/>
           </a:p>
@@ -1891,7 +1916,7 @@
       </p:sp>
       <p:sp>
         <p:nvSpPr>
-          <p:cNvPr id="13" name="Text 11"/>
+          <p:cNvPr id="14" name="Text 12"/>
           <p:cNvSpPr txBox="1"/>
           <p:nvPr/>
         </p:nvSpPr>
@@ -1922,7 +1947,7 @@
                 <a:ea typeface="Calibri" pitchFamily="34" charset="-122"/>
                 <a:cs typeface="Calibri" pitchFamily="34" charset="-120"/>
               </a:rPr>
-              <a:t>Chercher et comparer les solutions possibles</a:t>
+              <a:t>Fonctions + contraintes</a:t>
             </a:r>
             <a:endParaRPr lang="en-US" sz="1400" dirty="0"/>
           </a:p>
@@ -1930,7 +1955,32 @@
       </p:sp>
       <p:sp>
         <p:nvSpPr>
-          <p:cNvPr id="14" name="Shape 12"/>
+          <p:cNvPr id="15" name="Shape 13"/>
+          <p:cNvSpPr/>
+          <p:nvPr/>
+        </p:nvSpPr>
+        <p:spPr>
+          <a:xfrm>
+            <a:off x="4910328" y="4160520"/>
+            <a:ext cx="128016" cy="182880"/>
+          </a:xfrm>
+          <a:prstGeom prst="rightArrow">
+            <a:avLst/>
+          </a:prstGeom>
+          <a:solidFill>
+            <a:srgbClr val="2C5596"/>
+          </a:solidFill>
+          <a:ln w="12700">
+            <a:solidFill>
+              <a:srgbClr val="2C5596"/>
+            </a:solidFill>
+            <a:prstDash val="solid"/>
+          </a:ln>
+        </p:spPr>
+      </p:sp>
+      <p:sp>
+        <p:nvSpPr>
+          <p:cNvPr id="16" name="Shape 14"/>
           <p:cNvSpPr/>
           <p:nvPr/>
         </p:nvSpPr>
@@ -1964,7 +2014,7 @@
       </p:sp>
       <p:sp>
         <p:nvSpPr>
-          <p:cNvPr id="15" name="Shape 13"/>
+          <p:cNvPr id="17" name="Shape 15"/>
           <p:cNvSpPr/>
           <p:nvPr/>
         </p:nvSpPr>
@@ -1989,7 +2039,7 @@
       </p:sp>
       <p:sp>
         <p:nvSpPr>
-          <p:cNvPr id="16" name="Text 14"/>
+          <p:cNvPr id="18" name="Text 16"/>
           <p:cNvSpPr txBox="1"/>
           <p:nvPr/>
         </p:nvSpPr>
@@ -2028,7 +2078,7 @@
       </p:sp>
       <p:sp>
         <p:nvSpPr>
-          <p:cNvPr id="17" name="Text 15"/>
+          <p:cNvPr id="19" name="Text 17"/>
           <p:cNvSpPr txBox="1"/>
           <p:nvPr/>
         </p:nvSpPr>
@@ -2059,7 +2109,7 @@
                 <a:ea typeface="Cambria" pitchFamily="34" charset="-122"/>
                 <a:cs typeface="Cambria" pitchFamily="34" charset="-120"/>
               </a:rPr>
-              <a:t>Conception et simulation</a:t>
+              <a:t>Découper en blocs</a:t>
             </a:r>
             <a:endParaRPr lang="en-US" sz="1700" dirty="0"/>
           </a:p>
@@ -2067,7 +2117,7 @@
       </p:sp>
       <p:sp>
         <p:nvSpPr>
-          <p:cNvPr id="18" name="Text 16"/>
+          <p:cNvPr id="20" name="Text 18"/>
           <p:cNvSpPr txBox="1"/>
           <p:nvPr/>
         </p:nvSpPr>
@@ -2098,7 +2148,7 @@
                 <a:ea typeface="Calibri" pitchFamily="34" charset="-122"/>
                 <a:cs typeface="Calibri" pitchFamily="34" charset="-120"/>
               </a:rPr>
-              <a:t>Dessiner le schéma et le tester sur logiciel</a:t>
+              <a:t>Un rôle par bloc</a:t>
             </a:r>
             <a:endParaRPr lang="en-US" sz="1400" dirty="0"/>
           </a:p>
@@ -2106,7 +2156,32 @@
       </p:sp>
       <p:sp>
         <p:nvSpPr>
-          <p:cNvPr id="19" name="Shape 17"/>
+          <p:cNvPr id="21" name="Shape 19"/>
+          <p:cNvSpPr/>
+          <p:nvPr/>
+        </p:nvSpPr>
+        <p:spPr>
+          <a:xfrm>
+            <a:off x="7114032" y="4160520"/>
+            <a:ext cx="128016" cy="182880"/>
+          </a:xfrm>
+          <a:prstGeom prst="rightArrow">
+            <a:avLst/>
+          </a:prstGeom>
+          <a:solidFill>
+            <a:srgbClr val="2C5596"/>
+          </a:solidFill>
+          <a:ln w="12700">
+            <a:solidFill>
+              <a:srgbClr val="2C5596"/>
+            </a:solidFill>
+            <a:prstDash val="solid"/>
+          </a:ln>
+        </p:spPr>
+      </p:sp>
+      <p:sp>
+        <p:nvSpPr>
+          <p:cNvPr id="22" name="Shape 20"/>
           <p:cNvSpPr/>
           <p:nvPr/>
         </p:nvSpPr>
@@ -2140,7 +2215,7 @@
       </p:sp>
       <p:sp>
         <p:nvSpPr>
-          <p:cNvPr id="20" name="Shape 18"/>
+          <p:cNvPr id="23" name="Shape 21"/>
           <p:cNvSpPr/>
           <p:nvPr/>
         </p:nvSpPr>
@@ -2165,7 +2240,7 @@
       </p:sp>
       <p:sp>
         <p:nvSpPr>
-          <p:cNvPr id="21" name="Text 19"/>
+          <p:cNvPr id="24" name="Text 22"/>
           <p:cNvSpPr txBox="1"/>
           <p:nvPr/>
         </p:nvSpPr>
@@ -2204,7 +2279,7 @@
       </p:sp>
       <p:sp>
         <p:nvSpPr>
-          <p:cNvPr id="22" name="Text 20"/>
+          <p:cNvPr id="25" name="Text 23"/>
           <p:cNvSpPr txBox="1"/>
           <p:nvPr/>
         </p:nvSpPr>
@@ -2235,7 +2310,7 @@
                 <a:ea typeface="Cambria" pitchFamily="34" charset="-122"/>
                 <a:cs typeface="Cambria" pitchFamily="34" charset="-120"/>
               </a:rPr>
-              <a:t>Réalisation</a:t>
+              <a:t>Choisir les composants</a:t>
             </a:r>
             <a:endParaRPr lang="en-US" sz="1700" dirty="0"/>
           </a:p>
@@ -2243,7 +2318,7 @@
       </p:sp>
       <p:sp>
         <p:nvSpPr>
-          <p:cNvPr id="23" name="Text 21"/>
+          <p:cNvPr id="26" name="Text 24"/>
           <p:cNvSpPr txBox="1"/>
           <p:nvPr/>
         </p:nvSpPr>
@@ -2274,7 +2349,7 @@
                 <a:ea typeface="Calibri" pitchFamily="34" charset="-122"/>
                 <a:cs typeface="Calibri" pitchFamily="34" charset="-120"/>
               </a:rPr>
-              <a:t>Monter le prototype</a:t>
+              <a:t>Et le justifier</a:t>
             </a:r>
             <a:endParaRPr lang="en-US" sz="1400" dirty="0"/>
           </a:p>
@@ -2282,7 +2357,32 @@
       </p:sp>
       <p:sp>
         <p:nvSpPr>
-          <p:cNvPr id="24" name="Shape 22"/>
+          <p:cNvPr id="27" name="Shape 25"/>
+          <p:cNvSpPr/>
+          <p:nvPr/>
+        </p:nvSpPr>
+        <p:spPr>
+          <a:xfrm>
+            <a:off x="9317736" y="4160520"/>
+            <a:ext cx="128016" cy="182880"/>
+          </a:xfrm>
+          <a:prstGeom prst="rightArrow">
+            <a:avLst/>
+          </a:prstGeom>
+          <a:solidFill>
+            <a:srgbClr val="2C5596"/>
+          </a:solidFill>
+          <a:ln w="12700">
+            <a:solidFill>
+              <a:srgbClr val="2C5596"/>
+            </a:solidFill>
+            <a:prstDash val="solid"/>
+          </a:ln>
+        </p:spPr>
+      </p:sp>
+      <p:sp>
+        <p:nvSpPr>
+          <p:cNvPr id="28" name="Shape 26"/>
           <p:cNvSpPr/>
           <p:nvPr/>
         </p:nvSpPr>
@@ -2316,7 +2416,7 @@
       </p:sp>
       <p:sp>
         <p:nvSpPr>
-          <p:cNvPr id="25" name="Shape 23"/>
+          <p:cNvPr id="29" name="Shape 27"/>
           <p:cNvSpPr/>
           <p:nvPr/>
         </p:nvSpPr>
@@ -2341,7 +2441,7 @@
       </p:sp>
       <p:sp>
         <p:nvSpPr>
-          <p:cNvPr id="26" name="Text 24"/>
+          <p:cNvPr id="30" name="Text 28"/>
           <p:cNvSpPr txBox="1"/>
           <p:nvPr/>
         </p:nvSpPr>
@@ -2380,7 +2480,7 @@
       </p:sp>
       <p:sp>
         <p:nvSpPr>
-          <p:cNvPr id="27" name="Text 25"/>
+          <p:cNvPr id="31" name="Text 29"/>
           <p:cNvSpPr txBox="1"/>
           <p:nvPr/>
         </p:nvSpPr>
@@ -2411,7 +2511,7 @@
                 <a:ea typeface="Cambria" pitchFamily="34" charset="-122"/>
                 <a:cs typeface="Cambria" pitchFamily="34" charset="-120"/>
               </a:rPr>
-              <a:t>Tests et validation</a:t>
+              <a:t>Réaliser et tester</a:t>
             </a:r>
             <a:endParaRPr lang="en-US" sz="1700" dirty="0"/>
           </a:p>
@@ -2419,7 +2519,7 @@
       </p:sp>
       <p:sp>
         <p:nvSpPr>
-          <p:cNvPr id="28" name="Text 26"/>
+          <p:cNvPr id="32" name="Text 30"/>
           <p:cNvSpPr txBox="1"/>
           <p:nvPr/>
         </p:nvSpPr>
@@ -2450,7 +2550,7 @@
                 <a:ea typeface="Calibri" pitchFamily="34" charset="-122"/>
                 <a:cs typeface="Calibri" pitchFamily="34" charset="-120"/>
               </a:rPr>
-              <a:t>Vérifier que le projet répond au besoin</a:t>
+              <a:t>Étape par étape</a:t>
             </a:r>
             <a:endParaRPr lang="en-US" sz="1400" dirty="0"/>
           </a:p>
@@ -5729,7 +5829,7 @@
                 <a:ea typeface="Cambria" pitchFamily="34" charset="-122"/>
                 <a:cs typeface="Cambria" pitchFamily="34" charset="-120"/>
               </a:rPr>
-              <a:t>Chapitre 1 : les cinq étapes de conception</a:t>
+              <a:t>Chapitre 1 : les 5 étapes de la conception</a:t>
             </a:r>
             <a:endParaRPr lang="en-US" sz="3600" dirty="0"/>
           </a:p>
@@ -5866,7 +5966,7 @@
                 <a:ea typeface="Cambria" pitchFamily="34" charset="-122"/>
                 <a:cs typeface="Cambria" pitchFamily="34" charset="-120"/>
               </a:rPr>
-              <a:t>Cahier des charges</a:t>
+              <a:t>Analyser le besoin</a:t>
             </a:r>
             <a:endParaRPr lang="en-US" sz="2100" dirty="0"/>
           </a:p>
@@ -5905,7 +6005,7 @@
                 <a:ea typeface="Calibri" pitchFamily="34" charset="-122"/>
                 <a:cs typeface="Calibri" pitchFamily="34" charset="-120"/>
               </a:rPr>
-              <a:t>Définir le besoin et les contraintes</a:t>
+              <a:t>Quel problème ?</a:t>
             </a:r>
             <a:endParaRPr lang="en-US" sz="1700" dirty="0"/>
           </a:p>
@@ -6042,7 +6142,7 @@
                 <a:ea typeface="Cambria" pitchFamily="34" charset="-122"/>
                 <a:cs typeface="Cambria" pitchFamily="34" charset="-120"/>
               </a:rPr>
-              <a:t>Étude des solutions</a:t>
+              <a:t>Écrire le cahier des charges</a:t>
             </a:r>
             <a:endParaRPr lang="en-US" sz="2100" dirty="0"/>
           </a:p>
@@ -6081,7 +6181,7 @@
                 <a:ea typeface="Calibri" pitchFamily="34" charset="-122"/>
                 <a:cs typeface="Calibri" pitchFamily="34" charset="-120"/>
               </a:rPr>
-              <a:t>Chercher et comparer les solutions possibles</a:t>
+              <a:t>Fonctions + contraintes</a:t>
             </a:r>
             <a:endParaRPr lang="en-US" sz="1700" dirty="0"/>
           </a:p>
@@ -6218,7 +6318,7 @@
                 <a:ea typeface="Cambria" pitchFamily="34" charset="-122"/>
                 <a:cs typeface="Cambria" pitchFamily="34" charset="-120"/>
               </a:rPr>
-              <a:t>Conception et simulation</a:t>
+              <a:t>Découper en blocs</a:t>
             </a:r>
             <a:endParaRPr lang="en-US" sz="2100" dirty="0"/>
           </a:p>
@@ -6257,7 +6357,7 @@
                 <a:ea typeface="Calibri" pitchFamily="34" charset="-122"/>
                 <a:cs typeface="Calibri" pitchFamily="34" charset="-120"/>
               </a:rPr>
-              <a:t>Dessiner le schéma et le tester sur logiciel</a:t>
+              <a:t>Un rôle par bloc</a:t>
             </a:r>
             <a:endParaRPr lang="en-US" sz="1700" dirty="0"/>
           </a:p>
@@ -6394,7 +6494,7 @@
                 <a:ea typeface="Cambria" pitchFamily="34" charset="-122"/>
                 <a:cs typeface="Cambria" pitchFamily="34" charset="-120"/>
               </a:rPr>
-              <a:t>Réalisation</a:t>
+              <a:t>Choisir les composants</a:t>
             </a:r>
             <a:endParaRPr lang="en-US" sz="2100" dirty="0"/>
           </a:p>
@@ -6433,7 +6533,7 @@
                 <a:ea typeface="Calibri" pitchFamily="34" charset="-122"/>
                 <a:cs typeface="Calibri" pitchFamily="34" charset="-120"/>
               </a:rPr>
-              <a:t>Monter le prototype</a:t>
+              <a:t>Et le justifier</a:t>
             </a:r>
             <a:endParaRPr lang="en-US" sz="1700" dirty="0"/>
           </a:p>
@@ -6570,7 +6670,7 @@
                 <a:ea typeface="Cambria" pitchFamily="34" charset="-122"/>
                 <a:cs typeface="Cambria" pitchFamily="34" charset="-120"/>
               </a:rPr>
-              <a:t>Tests et validation</a:t>
+              <a:t>Réaliser et tester</a:t>
             </a:r>
             <a:endParaRPr lang="en-US" sz="2100" dirty="0"/>
           </a:p>
@@ -6609,7 +6709,7 @@
                 <a:ea typeface="Calibri" pitchFamily="34" charset="-122"/>
                 <a:cs typeface="Calibri" pitchFamily="34" charset="-120"/>
               </a:rPr>
-              <a:t>Vérifier que le projet répond au besoin</a:t>
+              <a:t>Étape par étape</a:t>
             </a:r>
             <a:endParaRPr lang="en-US" sz="1700" dirty="0"/>
           </a:p>

</xml_diff>